<commit_message>
Repair presentation Terra blockers
</commit_message>
<xml_diff>
--- a/tests/fixtures/presentations/research_group_meeting/visual_review_packet_source/research_group_meeting_regression.pptx
+++ b/tests/fixtures/presentations/research_group_meeting/visual_review_packet_source/research_group_meeting_regression.pptx
@@ -3282,8 +3282,8 @@
         </p:nvSpPr>
         <p:spPr>
           <a:xfrm>
-            <a:off x="8229600" y="1600200"/>
-            <a:ext cx="2971800" cy="1188720"/>
+            <a:off x="8229600" y="1481328"/>
+            <a:ext cx="2971800" cy="1417320"/>
           </a:xfrm>
           <a:prstGeom prst="rect">
             <a:avLst/>
@@ -3327,8 +3327,8 @@
         </p:nvSpPr>
         <p:spPr>
           <a:xfrm>
-            <a:off x="8284464" y="1645920"/>
-            <a:ext cx="2862072" cy="1097280"/>
+            <a:off x="8284464" y="1527048"/>
+            <a:ext cx="2862072" cy="1325880"/>
           </a:xfrm>
           <a:prstGeom prst="rect">
             <a:avLst/>
@@ -3342,7 +3342,7 @@
           <a:lstStyle/>
           <a:p>
             <a:pPr algn="ctr">
-              <a:defRPr sz="1220" b="1">
+              <a:defRPr sz="1150" b="1">
                 <a:solidFill>
                   <a:srgbClr val="0F766E"/>
                 </a:solidFill>
@@ -3354,7 +3354,7 @@
             </a:r>
             <a:br/>
             <a:r>
-              <a:t>Calibrated wins recall and burden error;</a:t>
+              <a:t>Calibrated wins recall; burden error is lower-is-better and lowest for Calibrated.</a:t>
             </a:r>
             <a:br/>
             <a:r>
@@ -4152,7 +4152,7 @@
         <p:spPr>
           <a:xfrm>
             <a:off x="5074920" y="1682496"/>
-            <a:ext cx="685800" cy="1060704"/>
+            <a:ext cx="521208" cy="987552"/>
           </a:xfrm>
           <a:prstGeom prst="line">
             <a:avLst/>
@@ -4178,9 +4178,44 @@
           </a:fontRef>
         </p:style>
       </p:cxnSp>
-      <p:sp>
-        <p:nvSpPr>
-          <p:cNvPr id="12" name="Rectangle 11"/>
+      <p:cxnSp>
+        <p:nvCxnSpPr>
+          <p:cNvPr id="12" name="Connector 11"/>
+          <p:cNvCxnSpPr/>
+          <p:nvPr/>
+        </p:nvCxnSpPr>
+        <p:spPr>
+          <a:xfrm>
+            <a:off x="5074920" y="1682496"/>
+            <a:ext cx="2679192" cy="1773936"/>
+          </a:xfrm>
+          <a:prstGeom prst="line">
+            <a:avLst/>
+          </a:prstGeom>
+          <a:ln w="13970">
+            <a:solidFill>
+              <a:srgbClr val="606977"/>
+            </a:solidFill>
+          </a:ln>
+        </p:spPr>
+        <p:style>
+          <a:lnRef idx="2">
+            <a:schemeClr val="accent1"/>
+          </a:lnRef>
+          <a:fillRef idx="0">
+            <a:schemeClr val="accent1"/>
+          </a:fillRef>
+          <a:effectRef idx="1">
+            <a:schemeClr val="accent1"/>
+          </a:effectRef>
+          <a:fontRef idx="minor">
+            <a:schemeClr val="tx1"/>
+          </a:fontRef>
+        </p:style>
+      </p:cxnSp>
+      <p:sp>
+        <p:nvSpPr>
+          <p:cNvPr id="13" name="Rectangle 12"/>
           <p:cNvSpPr/>
           <p:nvPr/>
         </p:nvSpPr>
@@ -4225,7 +4260,7 @@
       </p:sp>
       <p:sp>
         <p:nvSpPr>
-          <p:cNvPr id="13" name="TextBox 12"/>
+          <p:cNvPr id="14" name="TextBox 13"/>
           <p:cNvSpPr txBox="1"/>
           <p:nvPr/>
         </p:nvSpPr>
@@ -4269,7 +4304,7 @@
       </p:sp>
       <p:sp>
         <p:nvSpPr>
-          <p:cNvPr id="14" name="Rectangle 13"/>
+          <p:cNvPr id="15" name="Rectangle 14"/>
           <p:cNvSpPr/>
           <p:nvPr/>
         </p:nvSpPr>
@@ -4314,7 +4349,7 @@
       </p:sp>
       <p:sp>
         <p:nvSpPr>
-          <p:cNvPr id="15" name="TextBox 14"/>
+          <p:cNvPr id="16" name="TextBox 15"/>
           <p:cNvSpPr txBox="1"/>
           <p:nvPr/>
         </p:nvSpPr>
@@ -4354,7 +4389,7 @@
       </p:sp>
       <p:cxnSp>
         <p:nvCxnSpPr>
-          <p:cNvPr id="16" name="Connector 15"/>
+          <p:cNvPr id="17" name="Connector 16"/>
           <p:cNvCxnSpPr/>
           <p:nvPr/>
         </p:nvCxnSpPr>
@@ -4389,14 +4424,14 @@
       </p:cxnSp>
       <p:cxnSp>
         <p:nvCxnSpPr>
-          <p:cNvPr id="17" name="Connector 16"/>
+          <p:cNvPr id="18" name="Connector 17"/>
           <p:cNvCxnSpPr/>
           <p:nvPr/>
         </p:nvCxnSpPr>
         <p:spPr>
           <a:xfrm>
             <a:off x="5074920" y="2642616"/>
-            <a:ext cx="685800" cy="100584"/>
+            <a:ext cx="521208" cy="27432"/>
           </a:xfrm>
           <a:prstGeom prst="line">
             <a:avLst/>
@@ -4422,9 +4457,44 @@
           </a:fontRef>
         </p:style>
       </p:cxnSp>
-      <p:sp>
-        <p:nvSpPr>
-          <p:cNvPr id="18" name="Rectangle 17"/>
+      <p:cxnSp>
+        <p:nvCxnSpPr>
+          <p:cNvPr id="19" name="Connector 18"/>
+          <p:cNvCxnSpPr/>
+          <p:nvPr/>
+        </p:nvCxnSpPr>
+        <p:spPr>
+          <a:xfrm>
+            <a:off x="5074920" y="2642616"/>
+            <a:ext cx="2679192" cy="813816"/>
+          </a:xfrm>
+          <a:prstGeom prst="line">
+            <a:avLst/>
+          </a:prstGeom>
+          <a:ln w="13970">
+            <a:solidFill>
+              <a:srgbClr val="606977"/>
+            </a:solidFill>
+          </a:ln>
+        </p:spPr>
+        <p:style>
+          <a:lnRef idx="2">
+            <a:schemeClr val="accent1"/>
+          </a:lnRef>
+          <a:fillRef idx="0">
+            <a:schemeClr val="accent1"/>
+          </a:fillRef>
+          <a:effectRef idx="1">
+            <a:schemeClr val="accent1"/>
+          </a:effectRef>
+          <a:fontRef idx="minor">
+            <a:schemeClr val="tx1"/>
+          </a:fontRef>
+        </p:style>
+      </p:cxnSp>
+      <p:sp>
+        <p:nvSpPr>
+          <p:cNvPr id="20" name="Rectangle 19"/>
           <p:cNvSpPr/>
           <p:nvPr/>
         </p:nvSpPr>
@@ -4469,7 +4539,7 @@
       </p:sp>
       <p:sp>
         <p:nvSpPr>
-          <p:cNvPr id="19" name="TextBox 18"/>
+          <p:cNvPr id="21" name="TextBox 20"/>
           <p:cNvSpPr txBox="1"/>
           <p:nvPr/>
         </p:nvSpPr>
@@ -4513,7 +4583,7 @@
       </p:sp>
       <p:sp>
         <p:nvSpPr>
-          <p:cNvPr id="20" name="Rectangle 19"/>
+          <p:cNvPr id="22" name="Rectangle 21"/>
           <p:cNvSpPr/>
           <p:nvPr/>
         </p:nvSpPr>
@@ -4558,7 +4628,7 @@
       </p:sp>
       <p:sp>
         <p:nvSpPr>
-          <p:cNvPr id="21" name="TextBox 20"/>
+          <p:cNvPr id="23" name="TextBox 22"/>
           <p:cNvSpPr txBox="1"/>
           <p:nvPr/>
         </p:nvSpPr>
@@ -4598,7 +4668,7 @@
       </p:sp>
       <p:cxnSp>
         <p:nvCxnSpPr>
-          <p:cNvPr id="22" name="Connector 21"/>
+          <p:cNvPr id="24" name="Connector 23"/>
           <p:cNvCxnSpPr/>
           <p:nvPr/>
         </p:nvCxnSpPr>
@@ -4633,14 +4703,14 @@
       </p:cxnSp>
       <p:cxnSp>
         <p:nvCxnSpPr>
-          <p:cNvPr id="23" name="Connector 22"/>
+          <p:cNvPr id="25" name="Connector 24"/>
           <p:cNvCxnSpPr/>
           <p:nvPr/>
         </p:nvCxnSpPr>
         <p:spPr>
           <a:xfrm flipV="1">
-            <a:off x="5074920" y="2743200"/>
-            <a:ext cx="685800" cy="859536"/>
+            <a:off x="5074920" y="2670048"/>
+            <a:ext cx="521208" cy="932688"/>
           </a:xfrm>
           <a:prstGeom prst="line">
             <a:avLst/>
@@ -4666,16 +4736,51 @@
           </a:fontRef>
         </p:style>
       </p:cxnSp>
-      <p:sp>
-        <p:nvSpPr>
-          <p:cNvPr id="24" name="Rectangle 23"/>
+      <p:cxnSp>
+        <p:nvCxnSpPr>
+          <p:cNvPr id="26" name="Connector 25"/>
+          <p:cNvCxnSpPr/>
+          <p:nvPr/>
+        </p:nvCxnSpPr>
+        <p:spPr>
+          <a:xfrm flipV="1">
+            <a:off x="5074920" y="3456432"/>
+            <a:ext cx="2679192" cy="146304"/>
+          </a:xfrm>
+          <a:prstGeom prst="line">
+            <a:avLst/>
+          </a:prstGeom>
+          <a:ln w="13970">
+            <a:solidFill>
+              <a:srgbClr val="606977"/>
+            </a:solidFill>
+          </a:ln>
+        </p:spPr>
+        <p:style>
+          <a:lnRef idx="2">
+            <a:schemeClr val="accent1"/>
+          </a:lnRef>
+          <a:fillRef idx="0">
+            <a:schemeClr val="accent1"/>
+          </a:fillRef>
+          <a:effectRef idx="1">
+            <a:schemeClr val="accent1"/>
+          </a:effectRef>
+          <a:fontRef idx="minor">
+            <a:schemeClr val="tx1"/>
+          </a:fontRef>
+        </p:style>
+      </p:cxnSp>
+      <p:sp>
+        <p:nvSpPr>
+          <p:cNvPr id="27" name="Rectangle 26"/>
           <p:cNvSpPr/>
           <p:nvPr/>
         </p:nvSpPr>
         <p:spPr>
           <a:xfrm>
-            <a:off x="5715000" y="2176272"/>
-            <a:ext cx="2194560" cy="1143000"/>
+            <a:off x="5577840" y="2176272"/>
+            <a:ext cx="1874519" cy="1143000"/>
           </a:xfrm>
           <a:prstGeom prst="rect">
             <a:avLst/>
@@ -4713,14 +4818,14 @@
       </p:sp>
       <p:sp>
         <p:nvSpPr>
-          <p:cNvPr id="25" name="TextBox 24"/>
+          <p:cNvPr id="28" name="TextBox 27"/>
           <p:cNvSpPr txBox="1"/>
           <p:nvPr/>
         </p:nvSpPr>
         <p:spPr>
           <a:xfrm>
-            <a:off x="5769864" y="2221991"/>
-            <a:ext cx="2084831" cy="1051560"/>
+            <a:off x="5632703" y="2221991"/>
+            <a:ext cx="1764791" cy="1051560"/>
           </a:xfrm>
           <a:prstGeom prst="rect">
             <a:avLst/>
@@ -4734,7 +4839,7 @@
           <a:lstStyle/>
           <a:p>
             <a:pPr algn="ctr">
-              <a:defRPr sz="1120" b="1">
+              <a:defRPr sz="1070" b="1">
                 <a:solidFill>
                   <a:srgbClr val="9A6A16"/>
                 </a:solidFill>
@@ -4757,14 +4862,14 @@
       </p:sp>
       <p:cxnSp>
         <p:nvCxnSpPr>
-          <p:cNvPr id="26" name="Connector 25"/>
+          <p:cNvPr id="29" name="Connector 28"/>
           <p:cNvCxnSpPr/>
           <p:nvPr/>
         </p:nvCxnSpPr>
         <p:spPr>
-          <a:xfrm>
-            <a:off x="7973568" y="2743200"/>
-            <a:ext cx="420624" cy="0"/>
+          <a:xfrm flipV="1">
+            <a:off x="7498079" y="2057400"/>
+            <a:ext cx="256033" cy="612648"/>
           </a:xfrm>
           <a:prstGeom prst="line">
             <a:avLst/>
@@ -4792,14 +4897,14 @@
       </p:cxnSp>
       <p:sp>
         <p:nvSpPr>
-          <p:cNvPr id="27" name="Rectangle 26"/>
+          <p:cNvPr id="30" name="Rectangle 29"/>
           <p:cNvSpPr/>
           <p:nvPr/>
         </p:nvSpPr>
         <p:spPr>
           <a:xfrm>
-            <a:off x="8412480" y="1901952"/>
-            <a:ext cx="2926080" cy="868680"/>
+            <a:off x="7790688" y="1664208"/>
+            <a:ext cx="1874519" cy="786384"/>
           </a:xfrm>
           <a:prstGeom prst="rect">
             <a:avLst/>
@@ -4837,14 +4942,14 @@
       </p:sp>
       <p:sp>
         <p:nvSpPr>
-          <p:cNvPr id="28" name="TextBox 27"/>
+          <p:cNvPr id="31" name="TextBox 30"/>
           <p:cNvSpPr txBox="1"/>
           <p:nvPr/>
         </p:nvSpPr>
         <p:spPr>
           <a:xfrm>
-            <a:off x="8467344" y="1947672"/>
-            <a:ext cx="2816352" cy="777240"/>
+            <a:off x="7845552" y="1709928"/>
+            <a:ext cx="1764791" cy="694944"/>
           </a:xfrm>
           <a:prstGeom prst="rect">
             <a:avLst/>
@@ -4858,7 +4963,7 @@
           <a:lstStyle/>
           <a:p>
             <a:pPr algn="ctr">
-              <a:defRPr sz="1140" b="1">
+              <a:defRPr sz="1070" b="1">
                 <a:solidFill>
                   <a:srgbClr val="1F4E79"/>
                 </a:solidFill>
@@ -4870,21 +4975,106 @@
             </a:r>
             <a:br/>
             <a:r>
-              <a:t>compare local-only vs summary-sharing</a:t>
-            </a:r>
-          </a:p>
-        </p:txBody>
-      </p:sp>
-      <p:sp>
-        <p:nvSpPr>
-          <p:cNvPr id="29" name="Rectangle 28"/>
+              <a:t>summary-sharing analysis</a:t>
+            </a:r>
+          </a:p>
+        </p:txBody>
+      </p:sp>
+      <p:sp>
+        <p:nvSpPr>
+          <p:cNvPr id="32" name="Rectangle 31"/>
           <p:cNvSpPr/>
           <p:nvPr/>
         </p:nvSpPr>
         <p:spPr>
           <a:xfrm>
-            <a:off x="8412480" y="3456432"/>
-            <a:ext cx="2926080" cy="960120"/>
+            <a:off x="7790688" y="3035808"/>
+            <a:ext cx="1874519" cy="786384"/>
+          </a:xfrm>
+          <a:prstGeom prst="rect">
+            <a:avLst/>
+          </a:prstGeom>
+          <a:solidFill>
+            <a:srgbClr val="E1F4F1"/>
+          </a:solidFill>
+          <a:ln w="12700">
+            <a:solidFill>
+              <a:srgbClr val="C6CCD6"/>
+            </a:solidFill>
+          </a:ln>
+        </p:spPr>
+        <p:style>
+          <a:lnRef idx="1">
+            <a:schemeClr val="accent1"/>
+          </a:lnRef>
+          <a:fillRef idx="3">
+            <a:schemeClr val="accent1"/>
+          </a:fillRef>
+          <a:effectRef idx="2">
+            <a:schemeClr val="accent1"/>
+          </a:effectRef>
+          <a:fontRef idx="minor">
+            <a:schemeClr val="lt1"/>
+          </a:fontRef>
+        </p:style>
+        <p:txBody>
+          <a:bodyPr rtlCol="0" anchor="ctr"/>
+          <a:lstStyle/>
+          <a:p>
+            <a:pPr algn="ctr"/>
+          </a:p>
+        </p:txBody>
+      </p:sp>
+      <p:sp>
+        <p:nvSpPr>
+          <p:cNvPr id="33" name="TextBox 32"/>
+          <p:cNvSpPr txBox="1"/>
+          <p:nvPr/>
+        </p:nvSpPr>
+        <p:spPr>
+          <a:xfrm>
+            <a:off x="7845552" y="3081527"/>
+            <a:ext cx="1764791" cy="694944"/>
+          </a:xfrm>
+          <a:prstGeom prst="rect">
+            <a:avLst/>
+          </a:prstGeom>
+          <a:noFill/>
+        </p:spPr>
+        <p:txBody>
+          <a:bodyPr wrap="square" lIns="36576" rIns="36576" tIns="18288" bIns="18288">
+            <a:spAutoFit/>
+          </a:bodyPr>
+          <a:lstStyle/>
+          <a:p>
+            <a:pPr algn="ctr">
+              <a:defRPr sz="1070" b="1">
+                <a:solidFill>
+                  <a:srgbClr val="0F766E"/>
+                </a:solidFill>
+                <a:latin typeface="Aptos"/>
+              </a:defRPr>
+            </a:pPr>
+            <a:r>
+              <a:t>Local-only comparator</a:t>
+            </a:r>
+            <a:br/>
+            <a:r>
+              <a:t>no shared summaries</a:t>
+            </a:r>
+          </a:p>
+        </p:txBody>
+      </p:sp>
+      <p:sp>
+        <p:nvSpPr>
+          <p:cNvPr id="34" name="Rectangle 33"/>
+          <p:cNvSpPr/>
+          <p:nvPr/>
+        </p:nvSpPr>
+        <p:spPr>
+          <a:xfrm>
+            <a:off x="10012680" y="2331720"/>
+            <a:ext cx="1783080" cy="1051560"/>
           </a:xfrm>
           <a:prstGeom prst="rect">
             <a:avLst/>
@@ -4922,14 +5112,14 @@
       </p:sp>
       <p:sp>
         <p:nvSpPr>
-          <p:cNvPr id="30" name="TextBox 29"/>
+          <p:cNvPr id="35" name="TextBox 34"/>
           <p:cNvSpPr txBox="1"/>
           <p:nvPr/>
         </p:nvSpPr>
         <p:spPr>
           <a:xfrm>
-            <a:off x="8467344" y="3502151"/>
-            <a:ext cx="2816352" cy="868680"/>
+            <a:off x="10067544" y="2377439"/>
+            <a:ext cx="1673352" cy="960119"/>
           </a:xfrm>
           <a:prstGeom prst="rect">
             <a:avLst/>
@@ -4943,7 +5133,7 @@
           <a:lstStyle/>
           <a:p>
             <a:pPr algn="ctr">
-              <a:defRPr sz="1140" b="1">
+              <a:defRPr sz="1040" b="1">
                 <a:solidFill>
                   <a:srgbClr val="A33A34"/>
                 </a:solidFill>
@@ -4951,7 +5141,7 @@
               </a:defRPr>
             </a:pPr>
             <a:r>
-              <a:t>Success endpoint</a:t>
+              <a:t>Endpoint evaluation</a:t>
             </a:r>
             <a:br/>
             <a:r>
@@ -4964,9 +5154,79 @@
           </a:p>
         </p:txBody>
       </p:sp>
-      <p:sp>
-        <p:nvSpPr>
-          <p:cNvPr id="31" name="TextBox 30"/>
+      <p:cxnSp>
+        <p:nvCxnSpPr>
+          <p:cNvPr id="36" name="Connector 35"/>
+          <p:cNvCxnSpPr/>
+          <p:nvPr/>
+        </p:nvCxnSpPr>
+        <p:spPr>
+          <a:xfrm>
+            <a:off x="9710928" y="2057400"/>
+            <a:ext cx="274320" cy="685800"/>
+          </a:xfrm>
+          <a:prstGeom prst="line">
+            <a:avLst/>
+          </a:prstGeom>
+          <a:ln w="22860">
+            <a:solidFill>
+              <a:srgbClr val="4F1F68"/>
+            </a:solidFill>
+          </a:ln>
+        </p:spPr>
+        <p:style>
+          <a:lnRef idx="2">
+            <a:schemeClr val="accent1"/>
+          </a:lnRef>
+          <a:fillRef idx="0">
+            <a:schemeClr val="accent1"/>
+          </a:fillRef>
+          <a:effectRef idx="1">
+            <a:schemeClr val="accent1"/>
+          </a:effectRef>
+          <a:fontRef idx="minor">
+            <a:schemeClr val="tx1"/>
+          </a:fontRef>
+        </p:style>
+      </p:cxnSp>
+      <p:cxnSp>
+        <p:nvCxnSpPr>
+          <p:cNvPr id="37" name="Connector 36"/>
+          <p:cNvCxnSpPr/>
+          <p:nvPr/>
+        </p:nvCxnSpPr>
+        <p:spPr>
+          <a:xfrm flipV="1">
+            <a:off x="9710928" y="2999232"/>
+            <a:ext cx="274320" cy="457200"/>
+          </a:xfrm>
+          <a:prstGeom prst="line">
+            <a:avLst/>
+          </a:prstGeom>
+          <a:ln w="22860">
+            <a:solidFill>
+              <a:srgbClr val="4F1F68"/>
+            </a:solidFill>
+          </a:ln>
+        </p:spPr>
+        <p:style>
+          <a:lnRef idx="2">
+            <a:schemeClr val="accent1"/>
+          </a:lnRef>
+          <a:fillRef idx="0">
+            <a:schemeClr val="accent1"/>
+          </a:fillRef>
+          <a:effectRef idx="1">
+            <a:schemeClr val="accent1"/>
+          </a:effectRef>
+          <a:fontRef idx="minor">
+            <a:schemeClr val="tx1"/>
+          </a:fontRef>
+        </p:style>
+      </p:cxnSp>
+      <p:sp>
+        <p:nvSpPr>
+          <p:cNvPr id="38" name="TextBox 37"/>
           <p:cNvSpPr txBox="1"/>
           <p:nvPr/>
         </p:nvSpPr>
@@ -4995,14 +5255,14 @@
               </a:defRPr>
             </a:pPr>
             <a:r>
-              <a:t>Comparator: local-only model. What moves: score summaries and likelihood updates. What stays local: images, labels, case identifiers.</a:t>
-            </a:r>
-          </a:p>
-        </p:txBody>
-      </p:sp>
-      <p:sp>
-        <p:nvSpPr>
-          <p:cNvPr id="32" name="TextBox 31"/>
+              <a:t>Comparator path: local-only uses the same local scores without summary sharing; both branches enter the same endpoint gate.</a:t>
+            </a:r>
+          </a:p>
+        </p:txBody>
+      </p:sp>
+      <p:sp>
+        <p:nvSpPr>
+          <p:cNvPr id="39" name="TextBox 38"/>
           <p:cNvSpPr txBox="1"/>
           <p:nvPr/>
         </p:nvSpPr>

</xml_diff>

<commit_message>
Repair 015 visual evidence labels
</commit_message>
<xml_diff>
--- a/tests/fixtures/presentations/research_group_meeting/visual_review_packet_source/research_group_meeting_regression.pptx
+++ b/tests/fixtures/presentations/research_group_meeting/visual_review_packet_source/research_group_meeting_regression.pptx
@@ -3282,8 +3282,89 @@
         </p:nvSpPr>
         <p:spPr>
           <a:xfrm>
+            <a:off x="868680" y="1106424"/>
+            <a:ext cx="6766560" cy="256032"/>
+          </a:xfrm>
+          <a:prstGeom prst="rect">
+            <a:avLst/>
+          </a:prstGeom>
+          <a:solidFill>
+            <a:srgbClr val="FBF1D6"/>
+          </a:solidFill>
+          <a:ln w="12700">
+            <a:solidFill>
+              <a:srgbClr val="C6CCD6"/>
+            </a:solidFill>
+          </a:ln>
+        </p:spPr>
+        <p:style>
+          <a:lnRef idx="1">
+            <a:schemeClr val="accent1"/>
+          </a:lnRef>
+          <a:fillRef idx="3">
+            <a:schemeClr val="accent1"/>
+          </a:fillRef>
+          <a:effectRef idx="2">
+            <a:schemeClr val="accent1"/>
+          </a:effectRef>
+          <a:fontRef idx="minor">
+            <a:schemeClr val="lt1"/>
+          </a:fontRef>
+        </p:style>
+        <p:txBody>
+          <a:bodyPr rtlCol="0" anchor="ctr"/>
+          <a:lstStyle/>
+          <a:p>
+            <a:pPr algn="ctr"/>
+          </a:p>
+        </p:txBody>
+      </p:sp>
+      <p:sp>
+        <p:nvSpPr>
+          <p:cNvPr id="8" name="TextBox 7"/>
+          <p:cNvSpPr txBox="1"/>
+          <p:nvPr/>
+        </p:nvSpPr>
+        <p:spPr>
+          <a:xfrm>
+            <a:off x="923544" y="1152144"/>
+            <a:ext cx="6656832" cy="164592"/>
+          </a:xfrm>
+          <a:prstGeom prst="rect">
+            <a:avLst/>
+          </a:prstGeom>
+          <a:noFill/>
+        </p:spPr>
+        <p:txBody>
+          <a:bodyPr wrap="square" lIns="36576" rIns="36576" tIns="18288" bIns="18288">
+            <a:spAutoFit/>
+          </a:bodyPr>
+          <a:lstStyle/>
+          <a:p>
+            <a:pPr algn="ctr">
+              <a:defRPr sz="860" b="1">
+                <a:solidFill>
+                  <a:srgbClr val="9A6A16"/>
+                </a:solidFill>
+                <a:latin typeface="Aptos"/>
+              </a:defRPr>
+            </a:pPr>
+            <a:r>
+              <a:t>Evidence boundary: illustrative synthetic results - not completed validation</a:t>
+            </a:r>
+          </a:p>
+        </p:txBody>
+      </p:sp>
+      <p:sp>
+        <p:nvSpPr>
+          <p:cNvPr id="9" name="Rectangle 8"/>
+          <p:cNvSpPr/>
+          <p:nvPr/>
+        </p:nvSpPr>
+        <p:spPr>
+          <a:xfrm>
             <a:off x="8229600" y="1481328"/>
-            <a:ext cx="2971800" cy="1417320"/>
+            <a:ext cx="2971800" cy="1481328"/>
           </a:xfrm>
           <a:prstGeom prst="rect">
             <a:avLst/>
@@ -3321,14 +3402,14 @@
       </p:sp>
       <p:sp>
         <p:nvSpPr>
-          <p:cNvPr id="8" name="TextBox 7"/>
+          <p:cNvPr id="10" name="TextBox 9"/>
           <p:cNvSpPr txBox="1"/>
           <p:nvPr/>
         </p:nvSpPr>
         <p:spPr>
           <a:xfrm>
             <a:off x="8284464" y="1527048"/>
-            <a:ext cx="2862072" cy="1325880"/>
+            <a:ext cx="2862072" cy="1389888"/>
           </a:xfrm>
           <a:prstGeom prst="rect">
             <a:avLst/>
@@ -3342,7 +3423,7 @@
           <a:lstStyle/>
           <a:p>
             <a:pPr algn="ctr">
-              <a:defRPr sz="1150" b="1">
+              <a:defRPr sz="1110" b="1">
                 <a:solidFill>
                   <a:srgbClr val="0F766E"/>
                 </a:solidFill>
@@ -3354,7 +3435,7 @@
             </a:r>
             <a:br/>
             <a:r>
-              <a:t>Calibrated wins recall; burden error is lower-is-better and lowest for Calibrated.</a:t>
+              <a:t>In this synthetic example, Calibrated wins recall; burden error is lower-is-better and lowest for Calibrated.</a:t>
             </a:r>
             <a:br/>
             <a:r>
@@ -3365,7 +3446,7 @@
       </p:sp>
       <p:sp>
         <p:nvSpPr>
-          <p:cNvPr id="9" name="Rectangle 8"/>
+          <p:cNvPr id="11" name="Rectangle 10"/>
           <p:cNvSpPr/>
           <p:nvPr/>
         </p:nvSpPr>
@@ -3410,7 +3491,7 @@
       </p:sp>
       <p:sp>
         <p:nvSpPr>
-          <p:cNvPr id="10" name="TextBox 9"/>
+          <p:cNvPr id="12" name="TextBox 11"/>
           <p:cNvSpPr txBox="1"/>
           <p:nvPr/>
         </p:nvSpPr>
@@ -3450,7 +3531,7 @@
       </p:sp>
       <p:sp>
         <p:nvSpPr>
-          <p:cNvPr id="11" name="TextBox 10"/>
+          <p:cNvPr id="13" name="TextBox 12"/>
           <p:cNvSpPr txBox="1"/>
           <p:nvPr/>
         </p:nvSpPr>
@@ -3693,6 +3774,285 @@
         </p:nvSpPr>
         <p:spPr>
           <a:xfrm>
+            <a:off x="8641080" y="4462272"/>
+            <a:ext cx="1097280" cy="146304"/>
+          </a:xfrm>
+          <a:prstGeom prst="rect">
+            <a:avLst/>
+          </a:prstGeom>
+          <a:noFill/>
+        </p:spPr>
+        <p:txBody>
+          <a:bodyPr wrap="square" lIns="36576" rIns="36576" tIns="18288" bIns="18288">
+            <a:spAutoFit/>
+          </a:bodyPr>
+          <a:lstStyle/>
+          <a:p>
+            <a:pPr algn="l">
+              <a:defRPr sz="819" b="1">
+                <a:solidFill>
+                  <a:srgbClr val="606977"/>
+                </a:solidFill>
+                <a:latin typeface="Aptos"/>
+              </a:defRPr>
+            </a:pPr>
+            <a:r>
+              <a:t>Overlay legend</a:t>
+            </a:r>
+          </a:p>
+        </p:txBody>
+      </p:sp>
+      <p:sp>
+        <p:nvSpPr>
+          <p:cNvPr id="8" name="Rectangle 7"/>
+          <p:cNvSpPr/>
+          <p:nvPr/>
+        </p:nvSpPr>
+        <p:spPr>
+          <a:xfrm>
+            <a:off x="8641080" y="4645152"/>
+            <a:ext cx="109728" cy="109728"/>
+          </a:xfrm>
+          <a:prstGeom prst="rect">
+            <a:avLst/>
+          </a:prstGeom>
+          <a:solidFill>
+            <a:srgbClr val="0F766E"/>
+          </a:solidFill>
+          <a:ln w="6350">
+            <a:solidFill>
+              <a:srgbClr val="0F766E"/>
+            </a:solidFill>
+          </a:ln>
+        </p:spPr>
+        <p:style>
+          <a:lnRef idx="1">
+            <a:schemeClr val="accent1"/>
+          </a:lnRef>
+          <a:fillRef idx="3">
+            <a:schemeClr val="accent1"/>
+          </a:fillRef>
+          <a:effectRef idx="2">
+            <a:schemeClr val="accent1"/>
+          </a:effectRef>
+          <a:fontRef idx="minor">
+            <a:schemeClr val="lt1"/>
+          </a:fontRef>
+        </p:style>
+        <p:txBody>
+          <a:bodyPr rtlCol="0" anchor="ctr"/>
+          <a:lstStyle/>
+          <a:p>
+            <a:pPr algn="ctr"/>
+          </a:p>
+        </p:txBody>
+      </p:sp>
+      <p:sp>
+        <p:nvSpPr>
+          <p:cNvPr id="9" name="TextBox 8"/>
+          <p:cNvSpPr txBox="1"/>
+          <p:nvPr/>
+        </p:nvSpPr>
+        <p:spPr>
+          <a:xfrm>
+            <a:off x="8778240" y="4626864"/>
+            <a:ext cx="1325880" cy="146304"/>
+          </a:xfrm>
+          <a:prstGeom prst="rect">
+            <a:avLst/>
+          </a:prstGeom>
+          <a:noFill/>
+        </p:spPr>
+        <p:txBody>
+          <a:bodyPr wrap="square" lIns="36576" rIns="36576" tIns="18288" bIns="18288">
+            <a:spAutoFit/>
+          </a:bodyPr>
+          <a:lstStyle/>
+          <a:p>
+            <a:pPr algn="l">
+              <a:defRPr sz="819" b="0">
+                <a:solidFill>
+                  <a:srgbClr val="17202A"/>
+                </a:solidFill>
+                <a:latin typeface="Aptos"/>
+              </a:defRPr>
+            </a:pPr>
+            <a:r>
+              <a:t>green = TP/overlap</a:t>
+            </a:r>
+          </a:p>
+        </p:txBody>
+      </p:sp>
+      <p:sp>
+        <p:nvSpPr>
+          <p:cNvPr id="10" name="Rectangle 9"/>
+          <p:cNvSpPr/>
+          <p:nvPr/>
+        </p:nvSpPr>
+        <p:spPr>
+          <a:xfrm>
+            <a:off x="10058400" y="4645152"/>
+            <a:ext cx="109728" cy="109728"/>
+          </a:xfrm>
+          <a:prstGeom prst="rect">
+            <a:avLst/>
+          </a:prstGeom>
+          <a:solidFill>
+            <a:srgbClr val="A33A34"/>
+          </a:solidFill>
+          <a:ln w="6350">
+            <a:solidFill>
+              <a:srgbClr val="A33A34"/>
+            </a:solidFill>
+          </a:ln>
+        </p:spPr>
+        <p:style>
+          <a:lnRef idx="1">
+            <a:schemeClr val="accent1"/>
+          </a:lnRef>
+          <a:fillRef idx="3">
+            <a:schemeClr val="accent1"/>
+          </a:fillRef>
+          <a:effectRef idx="2">
+            <a:schemeClr val="accent1"/>
+          </a:effectRef>
+          <a:fontRef idx="minor">
+            <a:schemeClr val="lt1"/>
+          </a:fontRef>
+        </p:style>
+        <p:txBody>
+          <a:bodyPr rtlCol="0" anchor="ctr"/>
+          <a:lstStyle/>
+          <a:p>
+            <a:pPr algn="ctr"/>
+          </a:p>
+        </p:txBody>
+      </p:sp>
+      <p:sp>
+        <p:nvSpPr>
+          <p:cNvPr id="11" name="TextBox 10"/>
+          <p:cNvSpPr txBox="1"/>
+          <p:nvPr/>
+        </p:nvSpPr>
+        <p:spPr>
+          <a:xfrm>
+            <a:off x="10195560" y="4626864"/>
+            <a:ext cx="640080" cy="146304"/>
+          </a:xfrm>
+          <a:prstGeom prst="rect">
+            <a:avLst/>
+          </a:prstGeom>
+          <a:noFill/>
+        </p:spPr>
+        <p:txBody>
+          <a:bodyPr wrap="square" lIns="36576" rIns="36576" tIns="18288" bIns="18288">
+            <a:spAutoFit/>
+          </a:bodyPr>
+          <a:lstStyle/>
+          <a:p>
+            <a:pPr algn="l">
+              <a:defRPr sz="819" b="0">
+                <a:solidFill>
+                  <a:srgbClr val="17202A"/>
+                </a:solidFill>
+                <a:latin typeface="Aptos"/>
+              </a:defRPr>
+            </a:pPr>
+            <a:r>
+              <a:t>red = FP</a:t>
+            </a:r>
+          </a:p>
+        </p:txBody>
+      </p:sp>
+      <p:sp>
+        <p:nvSpPr>
+          <p:cNvPr id="12" name="Rectangle 11"/>
+          <p:cNvSpPr/>
+          <p:nvPr/>
+        </p:nvSpPr>
+        <p:spPr>
+          <a:xfrm>
+            <a:off x="10835640" y="4645152"/>
+            <a:ext cx="109728" cy="109728"/>
+          </a:xfrm>
+          <a:prstGeom prst="rect">
+            <a:avLst/>
+          </a:prstGeom>
+          <a:solidFill>
+            <a:srgbClr val="1F4E79"/>
+          </a:solidFill>
+          <a:ln w="6350">
+            <a:solidFill>
+              <a:srgbClr val="1F4E79"/>
+            </a:solidFill>
+          </a:ln>
+        </p:spPr>
+        <p:style>
+          <a:lnRef idx="1">
+            <a:schemeClr val="accent1"/>
+          </a:lnRef>
+          <a:fillRef idx="3">
+            <a:schemeClr val="accent1"/>
+          </a:fillRef>
+          <a:effectRef idx="2">
+            <a:schemeClr val="accent1"/>
+          </a:effectRef>
+          <a:fontRef idx="minor">
+            <a:schemeClr val="lt1"/>
+          </a:fontRef>
+        </p:style>
+        <p:txBody>
+          <a:bodyPr rtlCol="0" anchor="ctr"/>
+          <a:lstStyle/>
+          <a:p>
+            <a:pPr algn="ctr"/>
+          </a:p>
+        </p:txBody>
+      </p:sp>
+      <p:sp>
+        <p:nvSpPr>
+          <p:cNvPr id="13" name="TextBox 12"/>
+          <p:cNvSpPr txBox="1"/>
+          <p:nvPr/>
+        </p:nvSpPr>
+        <p:spPr>
+          <a:xfrm>
+            <a:off x="10972800" y="4626864"/>
+            <a:ext cx="713232" cy="146304"/>
+          </a:xfrm>
+          <a:prstGeom prst="rect">
+            <a:avLst/>
+          </a:prstGeom>
+          <a:noFill/>
+        </p:spPr>
+        <p:txBody>
+          <a:bodyPr wrap="square" lIns="36576" rIns="36576" tIns="18288" bIns="18288">
+            <a:spAutoFit/>
+          </a:bodyPr>
+          <a:lstStyle/>
+          <a:p>
+            <a:pPr algn="l">
+              <a:defRPr sz="819" b="0">
+                <a:solidFill>
+                  <a:srgbClr val="17202A"/>
+                </a:solidFill>
+                <a:latin typeface="Aptos"/>
+              </a:defRPr>
+            </a:pPr>
+            <a:r>
+              <a:t>blue = FN</a:t>
+            </a:r>
+          </a:p>
+        </p:txBody>
+      </p:sp>
+      <p:sp>
+        <p:nvSpPr>
+          <p:cNvPr id="14" name="TextBox 13"/>
+          <p:cNvSpPr txBox="1"/>
+          <p:nvPr/>
+        </p:nvSpPr>
+        <p:spPr>
+          <a:xfrm>
             <a:off x="868680" y="5806440"/>
             <a:ext cx="10241280" cy="292608"/>
           </a:xfrm>
@@ -3723,7 +4083,7 @@
       </p:sp>
       <p:sp>
         <p:nvSpPr>
-          <p:cNvPr id="8" name="TextBox 7"/>
+          <p:cNvPr id="15" name="TextBox 14"/>
           <p:cNvSpPr txBox="1"/>
           <p:nvPr/>
         </p:nvSpPr>

</xml_diff>